<commit_message>
Open punten huisstijl: vectorlogo, logovarianten en kleurproef
- Logo opnieuw opgebouwd als vector (SVG, PDF, PNG) in de kleuren van
  de site: volkleur, diapositief, blauw en wit, plus CMYK- en
  Pantone-PDF voor de drukker
- Kleurproef (A4) met CMYK-vlakken, Pantone-separaties en invulvakken
  voor de drukker
- Visitekaartje, briefpapier en PowerPoint-template gebruiken het
  nieuwe logo
- Brandguide: logovarianten, status in plaats van open punten

Co-Authored-By: Claude Opus 5.5 <noreply@anthropic.com>
Claude-Session: https://claude.ai/code/session_019FjnUhTF6nk5A2rERZua4r
</commit_message>
<xml_diff>
--- a/export/huisstijl/powerpoint-template-grip-op-stroom.pptx
+++ b/export/huisstijl/powerpoint-template-grip-op-stroom.pptx
@@ -112,12 +112,12 @@
   <p:extLst>
     <p:ext uri="{521415D9-36F7-43E2-AB2F-B90AF26B5E84}">
       <p14:sectionLst xmlns:p14="http://schemas.microsoft.com/office/powerpoint/2010/main">
-        <p14:section name="Opening" id="{39631563-a3d6-a172-8df7-6a13261b52e1}">
+        <p14:section name="Opening" id="{3cfb5ea5-6fde-021e-4bf0-6b9872d7d620}">
           <p14:sldIdLst>
             <p14:sldId id="256"/>
           </p14:sldIdLst>
         </p14:section>
-        <p14:section name="Het Gripplan" id="{c12270a4-ec8e-8fe5-8f10-99164c0d5bc9}">
+        <p14:section name="Het Gripplan" id="{2eee3b19-4e05-9974-54ca-5cec1cfebf5d}">
           <p14:sldIdLst>
             <p14:sldId id="257"/>
             <p14:sldId id="258"/>
@@ -125,7 +125,7 @@
             <p14:sldId id="260"/>
           </p14:sldIdLst>
         </p14:section>
-        <p14:section name="Afsluiting" id="{c45796b7-e251-04e4-d7f6-02279e1278af}">
+        <p14:section name="Afsluiting" id="{9fbeaa60-f4d5-61b4-d642-5826ecff1bb6}">
           <p14:sldIdLst>
             <p14:sldId id="261"/>
           </p14:sldIdLst>
@@ -1387,7 +1387,7 @@
       </p:sp>
       <p:pic>
         <p:nvPicPr>
-          <p:cNvPr id="5" name="Image 1" descr="/home/user/gripopstroom/assets/logo-gos.png">    </p:cNvPr>
+          <p:cNvPr id="5" name="Image 1" descr="logo-kleur-700.png">    </p:cNvPr>
           <p:cNvPicPr>
             <a:picLocks noChangeAspect="1"/>
           </p:cNvPicPr>
@@ -1488,7 +1488,7 @@
       </p:grpSpPr>
       <p:pic>
         <p:nvPicPr>
-          <p:cNvPr id="2" name="Image 0" descr="/home/user/gripopstroom/assets/logo-gos.png">    </p:cNvPr>
+          <p:cNvPr id="2" name="Image 0" descr="logo-kleur-700.png">    </p:cNvPr>
           <p:cNvPicPr>
             <a:picLocks noChangeAspect="1"/>
           </p:cNvPicPr>
@@ -1772,7 +1772,7 @@
       </p:grpSpPr>
       <p:pic>
         <p:nvPicPr>
-          <p:cNvPr id="2" name="Image 0" descr="/home/user/gripopstroom/assets/logo-gos.png">    </p:cNvPr>
+          <p:cNvPr id="2" name="Image 0" descr="logo-kleur-700.png">    </p:cNvPr>
           <p:cNvPicPr>
             <a:picLocks noChangeAspect="1"/>
           </p:cNvPicPr>
@@ -2003,7 +2003,7 @@
       </p:grpSpPr>
       <p:pic>
         <p:nvPicPr>
-          <p:cNvPr id="2" name="Image 0" descr="/home/user/gripopstroom/assets/logo-gos.png">    </p:cNvPr>
+          <p:cNvPr id="2" name="Image 0" descr="logo-kleur-700.png">    </p:cNvPr>
           <p:cNvPicPr>
             <a:picLocks noChangeAspect="1"/>
           </p:cNvPicPr>

</xml_diff>